<commit_message>
Update live platform link to https://panchaksharayya12.github.io/MatchNexa-AI/ across documentation and presentation deliverables
</commit_message>
<xml_diff>
--- a/MatchNexa_Presentation_Deck.pptx
+++ b/MatchNexa_Presentation_Deck.pptx
@@ -5857,7 +5857,7 @@
               </a:defRPr>
             </a:pPr>
             <a:r>
-              <a:t>Accessible locally at http://localhost:8050/index.html</a:t>
+              <a:t>Hosted live at https://panchaksharayya12.github.io/MatchNexa-AI/ (Local: http://localhost:8050/index.html)</a:t>
             </a:r>
           </a:p>
         </p:txBody>
@@ -11109,7 +11109,7 @@
               </a:defRPr>
             </a:pPr>
             <a:r>
-              <a:t>Live HTTP Console</a:t>
+              <a:t>Live Web Platform</a:t>
             </a:r>
           </a:p>
         </p:txBody>
@@ -11144,7 +11144,7 @@
               </a:defRPr>
             </a:pPr>
             <a:r>
-              <a:t>Running live on port 8050 with responsive data ledger, candidate explorer, and real-time simulator.</a:t>
+              <a:t>Hosted live at https://panchaksharayya12.github.io/MatchNexa-AI/ with responsive data ledger, candidate explorer, and real-time simulator.</a:t>
             </a:r>
           </a:p>
         </p:txBody>

</xml_diff>

<commit_message>
Add direct live Vercel production deployment link across repository and submission deliverables
</commit_message>
<xml_diff>
--- a/MatchNexa_Presentation_Deck.pptx
+++ b/MatchNexa_Presentation_Deck.pptx
@@ -5857,7 +5857,7 @@
               </a:defRPr>
             </a:pPr>
             <a:r>
-              <a:t>Hosted live at https://panchaksharayya12.github.io/MatchNexa-AI/ (Local: http://localhost:8050/index.html)</a:t>
+              <a:t>Hosted live on Vercel at https://match-nexa-ai.vercel.app (Mirror: https://panchaksharayya12.github.io/MatchNexa-AI/)</a:t>
             </a:r>
           </a:p>
         </p:txBody>
@@ -11144,7 +11144,7 @@
               </a:defRPr>
             </a:pPr>
             <a:r>
-              <a:t>Hosted live at https://panchaksharayya12.github.io/MatchNexa-AI/ with responsive data ledger, candidate explorer, and real-time simulator.</a:t>
+              <a:t>Hosted live on Vercel at https://match-nexa-ai.vercel.app with responsive data ledger, candidate explorer, and real-time simulator.</a:t>
             </a:r>
           </a:p>
         </p:txBody>

</xml_diff>